<commit_message>
Chrome contract P4-P5: fixtureVersion 6, matrix/compat re-record, docs, 0.1.2 metadata (V6 WP1)
</commit_message>
<xml_diff>
--- a/fixtures/golden/hello-merged.pptx
+++ b/fixtures/golden/hello-merged.pptx
@@ -2642,42 +2642,75 @@
       </p:sp>
       <p:sp>
         <p:nvSpPr>
-          <p:cNvPr id="10" name="Text 8"/>
-          <p:cNvSpPr/>
+          <p:cNvPr id="10" name="chrome-page-number"/>
+          <p:cNvSpPr txBox="1"/>
           <p:nvPr/>
         </p:nvSpPr>
         <p:spPr>
           <a:xfrm>
-            <a:off x="0" y="5494020"/>
-            <a:ext cx="11277600" cy="731520"/>
+            <a:off x="10360152" y="6172200"/>
+            <a:ext cx="1371600" cy="228600"/>
           </a:xfrm>
           <a:prstGeom prst="rect">
             <a:avLst/>
           </a:prstGeom>
           <a:noFill/>
-          <a:ln/>
         </p:spPr>
         <p:txBody>
-          <a:bodyPr wrap="none" lIns="0" tIns="0" rIns="0" bIns="0" rtlCol="0" anchor="t"/>
+          <a:bodyPr wrap="none" lIns="0" tIns="0" rIns="0" bIns="0" anchor="ctr">
+            <a:noAutofit/>
+          </a:bodyPr>
           <a:lstStyle/>
           <a:p>
-            <a:pPr algn="r" indent="0" marL="0">
-              <a:buNone/>
-            </a:pPr>
+            <a:pPr algn="r"/>
+            <a:fld id="{769bcc2d-d53b-523b-8db5-0da7700e7fc5}" type="slidenum">
+              <a:rPr lang="en-US" sz="900" dirty="0">
+                <a:solidFill>
+                  <a:srgbClr val="#5B6069"/>
+                </a:solidFill>
+                <a:latin typeface="Bower"/>
+                <a:ea typeface="Source Han Serif SC"/>
+                <a:cs typeface="Bower"/>
+              </a:rPr>
+              <a:t>‹#›</a:t>
+            </a:fld>
+          </a:p>
+        </p:txBody>
+      </p:sp>
+      <p:sp>
+        <p:nvSpPr>
+          <p:cNvPr id="11" name="chrome-footer"/>
+          <p:cNvSpPr txBox="1"/>
+          <p:nvPr/>
+        </p:nvSpPr>
+        <p:spPr>
+          <a:xfrm>
+            <a:off x="457200" y="6172200"/>
+            <a:ext cx="5486400" cy="228600"/>
+          </a:xfrm>
+          <a:prstGeom prst="rect">
+            <a:avLst/>
+          </a:prstGeom>
+          <a:noFill/>
+        </p:spPr>
+        <p:txBody>
+          <a:bodyPr wrap="none" lIns="0" tIns="0" rIns="0" bIns="0" anchor="ctr">
+            <a:noAutofit/>
+          </a:bodyPr>
+          <a:lstStyle/>
+          <a:p>
+            <a:pPr algn="l"/>
             <a:r>
-              <a:rPr lang="en-US" sz="4800" dirty="0">
+              <a:rPr lang="en-US" sz="900" dirty="0">
                 <a:solidFill>
-                  <a:srgbClr val="5B6069">
-                    <a:alpha val="30000"/>
-                  </a:srgbClr>
+                  <a:srgbClr val="#5B6069"/>
                 </a:solidFill>
-                <a:latin typeface="Georgia" pitchFamily="34" charset="0"/>
-                <a:ea typeface="Microsoft YaHei" pitchFamily="34" charset="-122"/>
-                <a:cs typeface="Georgia" pitchFamily="34" charset="-120"/>
+                <a:latin typeface="Bower"/>
+                <a:ea typeface="Source Han Serif SC"/>
+                <a:cs typeface="Bower"/>
               </a:rPr>
-              <a:t>02</a:t>
+              <a:t>dsh-ppt-fusion · golden fixture</a:t>
             </a:r>
-            <a:endParaRPr lang="en-US" sz="4800" dirty="0"/>
           </a:p>
         </p:txBody>
       </p:sp>
@@ -2845,6 +2878,117 @@
           </a:prstGeom>
         </p:spPr>
       </p:pic>
+      <p:sp>
+        <p:nvSpPr>
+          <p:cNvPr id="7" name="chrome-page-number"/>
+          <p:cNvSpPr txBox="1"/>
+          <p:nvPr/>
+        </p:nvSpPr>
+        <p:spPr>
+          <a:xfrm>
+            <a:off x="10360152" y="6172200"/>
+            <a:ext cx="1371600" cy="228600"/>
+          </a:xfrm>
+          <a:prstGeom prst="rect">
+            <a:avLst/>
+          </a:prstGeom>
+          <a:noFill/>
+        </p:spPr>
+        <p:txBody>
+          <a:bodyPr wrap="none" lIns="0" tIns="0" rIns="0" bIns="0" anchor="ctr">
+            <a:noAutofit/>
+          </a:bodyPr>
+          <a:lstStyle/>
+          <a:p>
+            <a:pPr algn="r"/>
+            <a:fld id="{0ec2eda5-17d4-5a57-a2d4-971ae3d79c0d}" type="slidenum">
+              <a:rPr lang="en-US" sz="900" dirty="0">
+                <a:solidFill>
+                  <a:srgbClr val="#5B6069"/>
+                </a:solidFill>
+                <a:latin typeface="Bower"/>
+                <a:ea typeface="Source Han Serif SC"/>
+                <a:cs typeface="Bower"/>
+              </a:rPr>
+              <a:t>‹#›</a:t>
+            </a:fld>
+          </a:p>
+        </p:txBody>
+      </p:sp>
+      <p:sp>
+        <p:nvSpPr>
+          <p:cNvPr id="8" name="chrome-footer"/>
+          <p:cNvSpPr txBox="1"/>
+          <p:nvPr/>
+        </p:nvSpPr>
+        <p:spPr>
+          <a:xfrm>
+            <a:off x="457200" y="6172200"/>
+            <a:ext cx="5486400" cy="228600"/>
+          </a:xfrm>
+          <a:prstGeom prst="rect">
+            <a:avLst/>
+          </a:prstGeom>
+          <a:noFill/>
+        </p:spPr>
+        <p:txBody>
+          <a:bodyPr wrap="none" lIns="0" tIns="0" rIns="0" bIns="0" anchor="ctr">
+            <a:noAutofit/>
+          </a:bodyPr>
+          <a:lstStyle/>
+          <a:p>
+            <a:pPr algn="l"/>
+            <a:r>
+              <a:rPr lang="en-US" sz="900" dirty="0">
+                <a:solidFill>
+                  <a:srgbClr val="#5B6069"/>
+                </a:solidFill>
+                <a:latin typeface="Bower"/>
+                <a:ea typeface="Source Han Serif SC"/>
+                <a:cs typeface="Bower"/>
+              </a:rPr>
+              <a:t>dsh-ppt-fusion · golden fixture</a:t>
+            </a:r>
+          </a:p>
+        </p:txBody>
+      </p:sp>
+      <p:sp>
+        <p:nvSpPr>
+          <p:cNvPr id="9" name="chrome-section"/>
+          <p:cNvSpPr txBox="1"/>
+          <p:nvPr/>
+        </p:nvSpPr>
+        <p:spPr>
+          <a:xfrm>
+            <a:off x="457200" y="274638"/>
+            <a:ext cx="4572000" cy="228600"/>
+          </a:xfrm>
+          <a:prstGeom prst="rect">
+            <a:avLst/>
+          </a:prstGeom>
+          <a:noFill/>
+        </p:spPr>
+        <p:txBody>
+          <a:bodyPr wrap="none" lIns="0" tIns="0" rIns="0" bIns="0" anchor="ctr">
+            <a:noAutofit/>
+          </a:bodyPr>
+          <a:lstStyle/>
+          <a:p>
+            <a:pPr algn="l"/>
+            <a:r>
+              <a:rPr lang="en-US" sz="900" dirty="0">
+                <a:solidFill>
+                  <a:srgbClr val="#5B6069"/>
+                </a:solidFill>
+                <a:latin typeface="Bower"/>
+                <a:ea typeface="Source Han Serif SC"/>
+                <a:cs typeface="Bower"/>
+              </a:rPr>
+              <a:t>深度引擎</a:t>
+            </a:r>
+          </a:p>
+        </p:txBody>
+      </p:sp>
     </p:spTree>
   </p:cSld>
   <p:clrMapOvr>
@@ -3619,6 +3763,80 @@
           </a:prstGeom>
         </p:spPr>
       </p:pic>
+      <p:sp>
+        <p:nvSpPr>
+          <p:cNvPr id="7" name="chrome-page-number"/>
+          <p:cNvSpPr txBox="1"/>
+          <p:nvPr/>
+        </p:nvSpPr>
+        <p:spPr>
+          <a:xfrm>
+            <a:off x="10360152" y="6172200"/>
+            <a:ext cx="1371600" cy="228600"/>
+          </a:xfrm>
+          <a:prstGeom prst="rect">
+            <a:avLst/>
+          </a:prstGeom>
+          <a:noFill/>
+        </p:spPr>
+        <p:txBody>
+          <a:bodyPr wrap="none" lIns="0" tIns="0" rIns="0" bIns="0" anchor="ctr">
+            <a:noAutofit/>
+          </a:bodyPr>
+          <a:lstStyle/>
+          <a:p>
+            <a:pPr algn="r"/>
+            <a:fld id="{77e496c3-b66a-57e9-bd1e-bc05c3adaf47}" type="slidenum">
+              <a:rPr lang="en-US" sz="900" dirty="0">
+                <a:solidFill>
+                  <a:srgbClr val="#5B6069"/>
+                </a:solidFill>
+                <a:latin typeface="Bower"/>
+                <a:ea typeface="Source Han Serif SC"/>
+                <a:cs typeface="Bower"/>
+              </a:rPr>
+              <a:t>‹#›</a:t>
+            </a:fld>
+          </a:p>
+        </p:txBody>
+      </p:sp>
+      <p:sp>
+        <p:nvSpPr>
+          <p:cNvPr id="8" name="chrome-footer"/>
+          <p:cNvSpPr txBox="1"/>
+          <p:nvPr/>
+        </p:nvSpPr>
+        <p:spPr>
+          <a:xfrm>
+            <a:off x="457200" y="6172200"/>
+            <a:ext cx="5486400" cy="228600"/>
+          </a:xfrm>
+          <a:prstGeom prst="rect">
+            <a:avLst/>
+          </a:prstGeom>
+          <a:noFill/>
+        </p:spPr>
+        <p:txBody>
+          <a:bodyPr wrap="none" lIns="0" tIns="0" rIns="0" bIns="0" anchor="ctr">
+            <a:noAutofit/>
+          </a:bodyPr>
+          <a:lstStyle/>
+          <a:p>
+            <a:pPr algn="l"/>
+            <a:r>
+              <a:rPr lang="en-US" sz="900" dirty="0">
+                <a:solidFill>
+                  <a:srgbClr val="#5B6069"/>
+                </a:solidFill>
+                <a:latin typeface="Bower"/>
+                <a:ea typeface="Source Han Serif SC"/>
+                <a:cs typeface="Bower"/>
+              </a:rPr>
+              <a:t>dsh-ppt-fusion · golden fixture</a:t>
+            </a:r>
+          </a:p>
+        </p:txBody>
+      </p:sp>
     </p:spTree>
   </p:cSld>
   <p:clrMapOvr>

</xml_diff>

<commit_message>
A2/Q5: recompute narration auto-advance from embedded audio and restore useTimings
</commit_message>
<xml_diff>
--- a/fixtures/golden/hello-merged.pptx
+++ b/fixtures/golden/hello-merged.pptx
@@ -2994,7 +2994,7 @@
   <p:clrMapOvr>
     <a:masterClrMapping/>
   </p:clrMapOvr>
-  <p:transition xmlns:p14="http://schemas.microsoft.com/office/powerpoint/2010/main" p14:dur="400">
+  <p:transition xmlns:p14="http://schemas.microsoft.com/office/powerpoint/2010/main" p14:dur="400" advClick="0" advTm="16500">
     <p:fade/>
   </p:transition>
   <p:timing>
@@ -3842,7 +3842,7 @@
   <p:clrMapOvr>
     <a:masterClrMapping/>
   </p:clrMapOvr>
-  <p:transition xmlns:p14="http://schemas.microsoft.com/office/powerpoint/2010/main" p14:dur="500">
+  <p:transition xmlns:p14="http://schemas.microsoft.com/office/powerpoint/2010/main" p14:dur="500" advClick="0" advTm="14604">
     <p:wipe dir="r"/>
   </p:transition>
   <p:timing>

</xml_diff>

<commit_message>
B4 profile audit: design-* rules, background contrast coverage and bare srgbClr literals (V7.2)
</commit_message>
<xml_diff>
--- a/fixtures/golden/hello-merged.pptx
+++ b/fixtures/golden/hello-merged.pptx
@@ -2666,7 +2666,7 @@
             <a:fld id="{769bcc2d-d53b-523b-8db5-0da7700e7fc5}" type="slidenum">
               <a:rPr lang="en-US" sz="900" dirty="0">
                 <a:solidFill>
-                  <a:srgbClr val="#5B6069"/>
+                  <a:srgbClr val="5B6069"/>
                 </a:solidFill>
                 <a:latin typeface="Bower"/>
                 <a:ea typeface="Source Han Serif SC"/>
@@ -2703,7 +2703,7 @@
             <a:r>
               <a:rPr lang="en-US" sz="900" dirty="0">
                 <a:solidFill>
-                  <a:srgbClr val="#5B6069"/>
+                  <a:srgbClr val="5B6069"/>
                 </a:solidFill>
                 <a:latin typeface="Bower"/>
                 <a:ea typeface="Source Han Serif SC"/>
@@ -2904,7 +2904,7 @@
             <a:fld id="{0ec2eda5-17d4-5a57-a2d4-971ae3d79c0d}" type="slidenum">
               <a:rPr lang="en-US" sz="900" dirty="0">
                 <a:solidFill>
-                  <a:srgbClr val="#5B6069"/>
+                  <a:srgbClr val="5B6069"/>
                 </a:solidFill>
                 <a:latin typeface="Bower"/>
                 <a:ea typeface="Source Han Serif SC"/>
@@ -2941,7 +2941,7 @@
             <a:r>
               <a:rPr lang="en-US" sz="900" dirty="0">
                 <a:solidFill>
-                  <a:srgbClr val="#5B6069"/>
+                  <a:srgbClr val="5B6069"/>
                 </a:solidFill>
                 <a:latin typeface="Bower"/>
                 <a:ea typeface="Source Han Serif SC"/>
@@ -2978,7 +2978,7 @@
             <a:r>
               <a:rPr lang="en-US" sz="900" dirty="0">
                 <a:solidFill>
-                  <a:srgbClr val="#5B6069"/>
+                  <a:srgbClr val="5B6069"/>
                 </a:solidFill>
                 <a:latin typeface="Bower"/>
                 <a:ea typeface="Source Han Serif SC"/>
@@ -3789,7 +3789,7 @@
             <a:fld id="{77e496c3-b66a-57e9-bd1e-bc05c3adaf47}" type="slidenum">
               <a:rPr lang="en-US" sz="900" dirty="0">
                 <a:solidFill>
-                  <a:srgbClr val="#5B6069"/>
+                  <a:srgbClr val="5B6069"/>
                 </a:solidFill>
                 <a:latin typeface="Bower"/>
                 <a:ea typeface="Source Han Serif SC"/>
@@ -3826,7 +3826,7 @@
             <a:r>
               <a:rPr lang="en-US" sz="900" dirty="0">
                 <a:solidFill>
-                  <a:srgbClr val="#5B6069"/>
+                  <a:srgbClr val="5B6069"/>
                 </a:solidFill>
                 <a:latin typeface="Bower"/>
                 <a:ea typeface="Source Han Serif SC"/>

</xml_diff>